<commit_message>
fix(presentation): correct OpenXML schema sequence for slide transitions
</commit_message>
<xml_diff>
--- a/computer_system_architecture.pptx
+++ b/computer_system_architecture.pptx
@@ -5154,9 +5154,6 @@
 
 <file path=ppt/slides/slide1.xml><?xml version="1.0" encoding="utf-8"?>
 <p:sld xmlns:a="http://schemas.openxmlformats.org/drawingml/2006/main" xmlns:p="http://schemas.openxmlformats.org/presentationml/2006/main" xmlns:r="http://schemas.openxmlformats.org/officeDocument/2006/relationships">
-  <p:transition spd="med">
-    <p:push dir="l"/>
-  </p:transition>
   <p:cSld>
     <p:bg>
       <p:bgPr>
@@ -5969,14 +5966,14 @@
   <p:clrMapOvr>
     <a:masterClrMapping/>
   </p:clrMapOvr>
+  <p:transition spd="med">
+    <p:push dir="l"/>
+  </p:transition>
 </p:sld>
 </file>
 
 <file path=ppt/slides/slide10.xml><?xml version="1.0" encoding="utf-8"?>
 <p:sld xmlns:a="http://schemas.openxmlformats.org/drawingml/2006/main" xmlns:p="http://schemas.openxmlformats.org/presentationml/2006/main" xmlns:r="http://schemas.openxmlformats.org/officeDocument/2006/relationships">
-  <p:transition spd="med">
-    <p:push dir="l"/>
-  </p:transition>
   <p:cSld>
     <p:bg>
       <p:bgPr>
@@ -6747,14 +6744,14 @@
   <p:clrMapOvr>
     <a:masterClrMapping/>
   </p:clrMapOvr>
+  <p:transition spd="med">
+    <p:push dir="l"/>
+  </p:transition>
 </p:sld>
 </file>
 
 <file path=ppt/slides/slide11.xml><?xml version="1.0" encoding="utf-8"?>
 <p:sld xmlns:a="http://schemas.openxmlformats.org/drawingml/2006/main" xmlns:p="http://schemas.openxmlformats.org/presentationml/2006/main" xmlns:r="http://schemas.openxmlformats.org/officeDocument/2006/relationships">
-  <p:transition spd="med">
-    <p:push dir="l"/>
-  </p:transition>
   <p:cSld>
     <p:bg>
       <p:bgPr>
@@ -7491,14 +7488,14 @@
   <p:clrMapOvr>
     <a:masterClrMapping/>
   </p:clrMapOvr>
+  <p:transition spd="med">
+    <p:push dir="l"/>
+  </p:transition>
 </p:sld>
 </file>
 
 <file path=ppt/slides/slide12.xml><?xml version="1.0" encoding="utf-8"?>
 <p:sld xmlns:a="http://schemas.openxmlformats.org/drawingml/2006/main" xmlns:p="http://schemas.openxmlformats.org/presentationml/2006/main" xmlns:r="http://schemas.openxmlformats.org/officeDocument/2006/relationships">
-  <p:transition spd="med">
-    <p:push dir="l"/>
-  </p:transition>
   <p:cSld>
     <p:bg>
       <p:bgPr>
@@ -8606,14 +8603,14 @@
   <p:clrMapOvr>
     <a:masterClrMapping/>
   </p:clrMapOvr>
+  <p:transition spd="med">
+    <p:push dir="l"/>
+  </p:transition>
 </p:sld>
 </file>
 
 <file path=ppt/slides/slide13.xml><?xml version="1.0" encoding="utf-8"?>
 <p:sld xmlns:a="http://schemas.openxmlformats.org/drawingml/2006/main" xmlns:p="http://schemas.openxmlformats.org/presentationml/2006/main" xmlns:r="http://schemas.openxmlformats.org/officeDocument/2006/relationships">
-  <p:transition spd="med">
-    <p:push dir="l"/>
-  </p:transition>
   <p:cSld>
     <p:bg>
       <p:bgPr>
@@ -9723,14 +9720,14 @@
   <p:clrMapOvr>
     <a:masterClrMapping/>
   </p:clrMapOvr>
+  <p:transition spd="med">
+    <p:push dir="l"/>
+  </p:transition>
 </p:sld>
 </file>
 
 <file path=ppt/slides/slide14.xml><?xml version="1.0" encoding="utf-8"?>
 <p:sld xmlns:a="http://schemas.openxmlformats.org/drawingml/2006/main" xmlns:p="http://schemas.openxmlformats.org/presentationml/2006/main" xmlns:r="http://schemas.openxmlformats.org/officeDocument/2006/relationships">
-  <p:transition spd="med">
-    <p:push dir="l"/>
-  </p:transition>
   <p:cSld>
     <p:bg>
       <p:bgPr>
@@ -10553,14 +10550,14 @@
   <p:clrMapOvr>
     <a:masterClrMapping/>
   </p:clrMapOvr>
+  <p:transition spd="med">
+    <p:push dir="l"/>
+  </p:transition>
 </p:sld>
 </file>
 
 <file path=ppt/slides/slide15.xml><?xml version="1.0" encoding="utf-8"?>
 <p:sld xmlns:a="http://schemas.openxmlformats.org/drawingml/2006/main" xmlns:p="http://schemas.openxmlformats.org/presentationml/2006/main" xmlns:r="http://schemas.openxmlformats.org/officeDocument/2006/relationships">
-  <p:transition spd="med">
-    <p:push dir="l"/>
-  </p:transition>
   <p:cSld>
     <p:bg>
       <p:bgPr>
@@ -11521,14 +11518,14 @@
   <p:clrMapOvr>
     <a:masterClrMapping/>
   </p:clrMapOvr>
+  <p:transition spd="med">
+    <p:push dir="l"/>
+  </p:transition>
 </p:sld>
 </file>
 
 <file path=ppt/slides/slide2.xml><?xml version="1.0" encoding="utf-8"?>
 <p:sld xmlns:a="http://schemas.openxmlformats.org/drawingml/2006/main" xmlns:p="http://schemas.openxmlformats.org/presentationml/2006/main" xmlns:r="http://schemas.openxmlformats.org/officeDocument/2006/relationships">
-  <p:transition spd="med">
-    <p:push dir="l"/>
-  </p:transition>
   <p:cSld>
     <p:bg>
       <p:bgPr>
@@ -12256,14 +12253,14 @@
   <p:clrMapOvr>
     <a:masterClrMapping/>
   </p:clrMapOvr>
+  <p:transition spd="med">
+    <p:push dir="l"/>
+  </p:transition>
 </p:sld>
 </file>
 
 <file path=ppt/slides/slide3.xml><?xml version="1.0" encoding="utf-8"?>
 <p:sld xmlns:a="http://schemas.openxmlformats.org/drawingml/2006/main" xmlns:p="http://schemas.openxmlformats.org/presentationml/2006/main" xmlns:r="http://schemas.openxmlformats.org/officeDocument/2006/relationships">
-  <p:transition spd="med">
-    <p:push dir="l"/>
-  </p:transition>
   <p:cSld>
     <p:bg>
       <p:bgPr>
@@ -13442,14 +13439,14 @@
   <p:clrMapOvr>
     <a:masterClrMapping/>
   </p:clrMapOvr>
+  <p:transition spd="med">
+    <p:push dir="l"/>
+  </p:transition>
 </p:sld>
 </file>
 
 <file path=ppt/slides/slide4.xml><?xml version="1.0" encoding="utf-8"?>
 <p:sld xmlns:a="http://schemas.openxmlformats.org/drawingml/2006/main" xmlns:p="http://schemas.openxmlformats.org/presentationml/2006/main" xmlns:r="http://schemas.openxmlformats.org/officeDocument/2006/relationships">
-  <p:transition spd="med">
-    <p:push dir="l"/>
-  </p:transition>
   <p:cSld>
     <p:bg>
       <p:bgPr>
@@ -14186,14 +14183,14 @@
   <p:clrMapOvr>
     <a:masterClrMapping/>
   </p:clrMapOvr>
+  <p:transition spd="med">
+    <p:push dir="l"/>
+  </p:transition>
 </p:sld>
 </file>
 
 <file path=ppt/slides/slide5.xml><?xml version="1.0" encoding="utf-8"?>
 <p:sld xmlns:a="http://schemas.openxmlformats.org/drawingml/2006/main" xmlns:p="http://schemas.openxmlformats.org/presentationml/2006/main" xmlns:r="http://schemas.openxmlformats.org/officeDocument/2006/relationships">
-  <p:transition spd="med">
-    <p:push dir="l"/>
-  </p:transition>
   <p:cSld>
     <p:bg>
       <p:bgPr>
@@ -14930,14 +14927,14 @@
   <p:clrMapOvr>
     <a:masterClrMapping/>
   </p:clrMapOvr>
+  <p:transition spd="med">
+    <p:push dir="l"/>
+  </p:transition>
 </p:sld>
 </file>
 
 <file path=ppt/slides/slide6.xml><?xml version="1.0" encoding="utf-8"?>
 <p:sld xmlns:a="http://schemas.openxmlformats.org/drawingml/2006/main" xmlns:p="http://schemas.openxmlformats.org/presentationml/2006/main" xmlns:r="http://schemas.openxmlformats.org/officeDocument/2006/relationships">
-  <p:transition spd="med">
-    <p:push dir="l"/>
-  </p:transition>
   <p:cSld>
     <p:bg>
       <p:bgPr>
@@ -15941,14 +15938,14 @@
   <p:clrMapOvr>
     <a:masterClrMapping/>
   </p:clrMapOvr>
+  <p:transition spd="med">
+    <p:push dir="l"/>
+  </p:transition>
 </p:sld>
 </file>
 
 <file path=ppt/slides/slide7.xml><?xml version="1.0" encoding="utf-8"?>
 <p:sld xmlns:a="http://schemas.openxmlformats.org/drawingml/2006/main" xmlns:p="http://schemas.openxmlformats.org/presentationml/2006/main" xmlns:r="http://schemas.openxmlformats.org/officeDocument/2006/relationships">
-  <p:transition spd="med">
-    <p:push dir="l"/>
-  </p:transition>
   <p:cSld>
     <p:bg>
       <p:bgPr>
@@ -17056,14 +17053,14 @@
   <p:clrMapOvr>
     <a:masterClrMapping/>
   </p:clrMapOvr>
+  <p:transition spd="med">
+    <p:push dir="l"/>
+  </p:transition>
 </p:sld>
 </file>
 
 <file path=ppt/slides/slide8.xml><?xml version="1.0" encoding="utf-8"?>
 <p:sld xmlns:a="http://schemas.openxmlformats.org/drawingml/2006/main" xmlns:p="http://schemas.openxmlformats.org/presentationml/2006/main" xmlns:r="http://schemas.openxmlformats.org/officeDocument/2006/relationships">
-  <p:transition spd="med">
-    <p:push dir="l"/>
-  </p:transition>
   <p:cSld>
     <p:bg>
       <p:bgPr>
@@ -17800,14 +17797,14 @@
   <p:clrMapOvr>
     <a:masterClrMapping/>
   </p:clrMapOvr>
+  <p:transition spd="med">
+    <p:push dir="l"/>
+  </p:transition>
 </p:sld>
 </file>
 
 <file path=ppt/slides/slide9.xml><?xml version="1.0" encoding="utf-8"?>
 <p:sld xmlns:a="http://schemas.openxmlformats.org/drawingml/2006/main" xmlns:p="http://schemas.openxmlformats.org/presentationml/2006/main" xmlns:r="http://schemas.openxmlformats.org/officeDocument/2006/relationships">
-  <p:transition spd="med">
-    <p:push dir="l"/>
-  </p:transition>
   <p:cSld>
     <p:bg>
       <p:bgPr>
@@ -18915,6 +18912,9 @@
   <p:clrMapOvr>
     <a:masterClrMapping/>
   </p:clrMapOvr>
+  <p:transition spd="med">
+    <p:push dir="l"/>
+  </p:transition>
 </p:sld>
 </file>
 

</xml_diff>